<commit_message>
style(case-study): update PPT and preview after editorial cleanup
</commit_message>
<xml_diff>
--- a/src/case-study/downloads/footmate_report.pptx
+++ b/src/case-study/downloads/footmate_report.pptx
@@ -4928,7 +4928,7 @@
                 <a:ea typeface="Do Hyeon"/>
                 <a:cs typeface="Do Hyeon"/>
               </a:rPr>
-              <a:t>FootMate · 가정·합성 데이터 기반 / 실제 사업 실적 아님</a:t>
+              <a:t>FootMate · 사업·IT 기획</a:t>
             </a:r>
           </a:p>
         </p:txBody>
@@ -5451,7 +5451,7 @@
                 <a:ea typeface="Do Hyeon"/>
                 <a:cs typeface="Do Hyeon"/>
               </a:rPr>
-              <a:t>FootMate · 가정·합성 데이터 기반 / 실제 사업 실적 아님</a:t>
+              <a:t>FootMate · 사업·IT 기획</a:t>
             </a:r>
           </a:p>
         </p:txBody>
@@ -6022,7 +6022,7 @@
                 <a:ea typeface="Do Hyeon"/>
                 <a:cs typeface="Do Hyeon"/>
               </a:rPr>
-              <a:t>전체 정원과 수익 대상 거래를 구분</a:t>
+              <a:t>기준 가정 · 정원과 경유 예약 구분</a:t>
             </a:r>
           </a:p>
         </p:txBody>
@@ -6179,7 +6179,7 @@
                 <a:ea typeface="Do Hyeon"/>
                 <a:cs typeface="Do Hyeon"/>
               </a:rPr>
-              <a:t>FootMate · 가정·합성 데이터 기반 / 실제 사업 실적 아님</a:t>
+              <a:t>FootMate · 사업·IT 기획</a:t>
             </a:r>
           </a:p>
         </p:txBody>
@@ -7003,7 +7003,7 @@
                 <a:ea typeface="Do Hyeon"/>
                 <a:cs typeface="Do Hyeon"/>
               </a:rPr>
-              <a:t>FootMate · 가정·합성 데이터 기반 / 실제 사업 실적 아님</a:t>
+              <a:t>FootMate · 사업·IT 기획</a:t>
             </a:r>
           </a:p>
         </p:txBody>
@@ -7902,7 +7902,7 @@
                 <a:ea typeface="Do Hyeon"/>
                 <a:cs typeface="Do Hyeon"/>
               </a:rPr>
-              <a:t>FootMate · 가정·합성 데이터 기반 / 실제 사업 실적 아님</a:t>
+              <a:t>FootMate · 사업·IT 기획</a:t>
             </a:r>
           </a:p>
         </p:txBody>
@@ -8081,7 +8081,7 @@
                 <a:ea typeface="Do Hyeon"/>
                 <a:cs typeface="Do Hyeon"/>
               </a:rPr>
-              <a:t>상반기 합성 실적과 하반기 계획을 연결한 예측</a:t>
+              <a:t>상반기 모형 거래·하반기 전망 비교</a:t>
             </a:r>
           </a:p>
         </p:txBody>
@@ -8424,7 +8424,7 @@
                 <a:ea typeface="Do Hyeon"/>
                 <a:cs typeface="Do Hyeon"/>
               </a:rPr>
-              <a:t>FootMate · 가정·합성 데이터 기반 / 실제 사업 실적 아님</a:t>
+              <a:t>FootMate · 사업·IT 기획</a:t>
             </a:r>
           </a:p>
         </p:txBody>
@@ -8469,7 +8469,7 @@
                           <a:ea typeface="Do Hyeon"/>
                           <a:cs typeface="Do Hyeon"/>
                         </a:rPr>
-                        <a:t>6월 차이</a:t>
+                        <a:t>6월 모형 차이</a:t>
                       </a:r>
                     </a:p>
                   </a:txBody>
@@ -9166,7 +9166,7 @@
                 <a:ea typeface="Do Hyeon"/>
                 <a:cs typeface="Do Hyeon"/>
               </a:rPr>
-              <a:t>FootMate · 가정·합성 데이터 기반 / 실제 사업 실적 아님</a:t>
+              <a:t>FootMate · 사업·IT 기획</a:t>
             </a:r>
           </a:p>
         </p:txBody>
@@ -9787,7 +9787,7 @@
                 <a:ea typeface="Do Hyeon"/>
                 <a:cs typeface="Do Hyeon"/>
               </a:rPr>
-              <a:t>FootMate · 가정·합성 데이터 기반 / 실제 사업 실적 아님</a:t>
+              <a:t>FootMate · 사업·IT 기획</a:t>
             </a:r>
           </a:p>
         </p:txBody>
@@ -10408,7 +10408,7 @@
                 <a:ea typeface="Do Hyeon"/>
                 <a:cs typeface="Do Hyeon"/>
               </a:rPr>
-              <a:t>FootMate · 가정·합성 데이터 기반 / 실제 사업 실적 아님</a:t>
+              <a:t>FootMate · 사업·IT 기획</a:t>
             </a:r>
           </a:p>
         </p:txBody>

</xml_diff>

<commit_message>
style(case-study): remove repetitive disclaimers from body and PPT (#763)
* style(case-study): concise copy and synchronized PPT update

* style(case-study): update PPT and preview after editorial cleanup

* chore(case-study): remove one-time PPT editing workflow

* test(case-study): assert user confirmation using concise wording

---------

Co-authored-by: github-actions[bot] <41898282+github-actions[bot]@users.noreply.github.com>
</commit_message>
<xml_diff>
--- a/src/case-study/downloads/footmate_report.pptx
+++ b/src/case-study/downloads/footmate_report.pptx
@@ -4928,7 +4928,7 @@
                 <a:ea typeface="Do Hyeon"/>
                 <a:cs typeface="Do Hyeon"/>
               </a:rPr>
-              <a:t>FootMate · 가정·합성 데이터 기반 / 실제 사업 실적 아님</a:t>
+              <a:t>FootMate · 사업·IT 기획</a:t>
             </a:r>
           </a:p>
         </p:txBody>
@@ -5451,7 +5451,7 @@
                 <a:ea typeface="Do Hyeon"/>
                 <a:cs typeface="Do Hyeon"/>
               </a:rPr>
-              <a:t>FootMate · 가정·합성 데이터 기반 / 실제 사업 실적 아님</a:t>
+              <a:t>FootMate · 사업·IT 기획</a:t>
             </a:r>
           </a:p>
         </p:txBody>
@@ -6022,7 +6022,7 @@
                 <a:ea typeface="Do Hyeon"/>
                 <a:cs typeface="Do Hyeon"/>
               </a:rPr>
-              <a:t>전체 정원과 수익 대상 거래를 구분</a:t>
+              <a:t>기준 가정 · 정원과 경유 예약 구분</a:t>
             </a:r>
           </a:p>
         </p:txBody>
@@ -6179,7 +6179,7 @@
                 <a:ea typeface="Do Hyeon"/>
                 <a:cs typeface="Do Hyeon"/>
               </a:rPr>
-              <a:t>FootMate · 가정·합성 데이터 기반 / 실제 사업 실적 아님</a:t>
+              <a:t>FootMate · 사업·IT 기획</a:t>
             </a:r>
           </a:p>
         </p:txBody>
@@ -7003,7 +7003,7 @@
                 <a:ea typeface="Do Hyeon"/>
                 <a:cs typeface="Do Hyeon"/>
               </a:rPr>
-              <a:t>FootMate · 가정·합성 데이터 기반 / 실제 사업 실적 아님</a:t>
+              <a:t>FootMate · 사업·IT 기획</a:t>
             </a:r>
           </a:p>
         </p:txBody>
@@ -7902,7 +7902,7 @@
                 <a:ea typeface="Do Hyeon"/>
                 <a:cs typeface="Do Hyeon"/>
               </a:rPr>
-              <a:t>FootMate · 가정·합성 데이터 기반 / 실제 사업 실적 아님</a:t>
+              <a:t>FootMate · 사업·IT 기획</a:t>
             </a:r>
           </a:p>
         </p:txBody>
@@ -8081,7 +8081,7 @@
                 <a:ea typeface="Do Hyeon"/>
                 <a:cs typeface="Do Hyeon"/>
               </a:rPr>
-              <a:t>상반기 합성 실적과 하반기 계획을 연결한 예측</a:t>
+              <a:t>상반기 모형 거래·하반기 전망 비교</a:t>
             </a:r>
           </a:p>
         </p:txBody>
@@ -8424,7 +8424,7 @@
                 <a:ea typeface="Do Hyeon"/>
                 <a:cs typeface="Do Hyeon"/>
               </a:rPr>
-              <a:t>FootMate · 가정·합성 데이터 기반 / 실제 사업 실적 아님</a:t>
+              <a:t>FootMate · 사업·IT 기획</a:t>
             </a:r>
           </a:p>
         </p:txBody>
@@ -8469,7 +8469,7 @@
                           <a:ea typeface="Do Hyeon"/>
                           <a:cs typeface="Do Hyeon"/>
                         </a:rPr>
-                        <a:t>6월 차이</a:t>
+                        <a:t>6월 모형 차이</a:t>
                       </a:r>
                     </a:p>
                   </a:txBody>
@@ -9166,7 +9166,7 @@
                 <a:ea typeface="Do Hyeon"/>
                 <a:cs typeface="Do Hyeon"/>
               </a:rPr>
-              <a:t>FootMate · 가정·합성 데이터 기반 / 실제 사업 실적 아님</a:t>
+              <a:t>FootMate · 사업·IT 기획</a:t>
             </a:r>
           </a:p>
         </p:txBody>
@@ -9787,7 +9787,7 @@
                 <a:ea typeface="Do Hyeon"/>
                 <a:cs typeface="Do Hyeon"/>
               </a:rPr>
-              <a:t>FootMate · 가정·합성 데이터 기반 / 실제 사업 실적 아님</a:t>
+              <a:t>FootMate · 사업·IT 기획</a:t>
             </a:r>
           </a:p>
         </p:txBody>
@@ -10408,7 +10408,7 @@
                 <a:ea typeface="Do Hyeon"/>
                 <a:cs typeface="Do Hyeon"/>
               </a:rPr>
-              <a:t>FootMate · 가정·합성 데이터 기반 / 실제 사업 실적 아님</a:t>
+              <a:t>FootMate · 사업·IT 기획</a:t>
             </a:r>
           </a:p>
         </p:txBody>

</xml_diff>